<commit_message>
feat(sampling): soil-configuration + forcing coverage panels in the design figure
Per user: the planning slide now shows WHAT the design sampled, not just
where. sampling_design.png grows to 2x3: P5 'soil configurations sampled'
(max clay vs min Ksat per column, texture markers, band colors) and P6
'forcing sampled' (NLDAS annual precip vs elevation for --forcing-year,
nearest 12 km cell via lazy point reads over the monthly files; graceful
skip if unavailable). Presented as design-space coverage scatter — readable
at N=20 (per-column detail stays in the appendix table). Re-rendered for
the Naches studies; deck regenerated.

Co-Authored-By: Claude Opus 4.8 <noreply@anthropic.com>
</commit_message>
<xml_diff>
--- a/docs/slides/story_20260706.pptx
+++ b/docs/slides/story_20260706.pptx
@@ -3904,8 +3904,8 @@
         </p:blipFill>
         <p:spPr>
           <a:xfrm>
-            <a:off x="2595728" y="1005840"/>
-            <a:ext cx="7000239" cy="4846320"/>
+            <a:off x="1384147" y="1005840"/>
+            <a:ext cx="9423400" cy="4846320"/>
           </a:xfrm>
           <a:prstGeom prst="rect">
             <a:avLst/>
@@ -6076,7 +6076,7 @@
         <p:spPr>
           <a:xfrm>
             <a:off x="1097280" y="1143000"/>
-            <a:ext cx="7528560" cy="5212080"/>
+            <a:ext cx="10134600" cy="5212080"/>
           </a:xfrm>
           <a:prstGeom prst="rect">
             <a:avLst/>
@@ -14524,7 +14524,7 @@
                         <a:defRPr sz="900"/>
                       </a:pPr>
                       <a:r>
-                        <a:t>&gt;cap</a:t>
+                        <a:t>—</a:t>
                       </a:r>
                     </a:p>
                   </a:txBody>
@@ -15744,7 +15744,7 @@
                         <a:defRPr sz="900"/>
                       </a:pPr>
                       <a:r>
-                        <a:t>&gt;cap</a:t>
+                        <a:t>—</a:t>
                       </a:r>
                     </a:p>
                   </a:txBody>
@@ -15866,7 +15866,7 @@
                         <a:defRPr sz="900"/>
                       </a:pPr>
                       <a:r>
-                        <a:t>&gt;cap</a:t>
+                        <a:t>—</a:t>
                       </a:r>
                     </a:p>
                   </a:txBody>
@@ -16354,7 +16354,7 @@
                         <a:defRPr sz="900"/>
                       </a:pPr>
                       <a:r>
-                        <a:t>&gt;cap</a:t>
+                        <a:t>—</a:t>
                       </a:r>
                     </a:p>
                   </a:txBody>
@@ -16476,7 +16476,7 @@
                         <a:defRPr sz="900"/>
                       </a:pPr>
                       <a:r>
-                        <a:t>&gt;cap</a:t>
+                        <a:t>—</a:t>
                       </a:r>
                     </a:p>
                   </a:txBody>
@@ -16598,7 +16598,7 @@
                         <a:defRPr sz="900"/>
                       </a:pPr>
                       <a:r>
-                        <a:t>&gt;cap</a:t>
+                        <a:t>—</a:t>
                       </a:r>
                     </a:p>
                   </a:txBody>
@@ -16970,8 +16970,8 @@
         </p:blipFill>
         <p:spPr>
           <a:xfrm>
-            <a:off x="2595728" y="1005840"/>
-            <a:ext cx="7000239" cy="4846320"/>
+            <a:off x="1384147" y="1005840"/>
+            <a:ext cx="9423400" cy="4846320"/>
           </a:xfrm>
           <a:prstGeom prst="rect">
             <a:avLst/>

</xml_diff>